<commit_message>
Publish Week 4 deployment research, four PDF deliverables and anonymized documents
</commit_message>
<xml_diff>
--- a/presentation/phase1-llm-industry-2026-09-10/output/fund-llm-industry-2026-09-10-final.pptx
+++ b/presentation/phase1-llm-industry-2026-09-10/output/fund-llm-industry-2026-09-10-final.pptx
@@ -2,36 +2,36 @@
 <file path=ppt/presentation.xml><?xml version="1.0" encoding="utf-8"?>
 <p:presentation xmlns:p="http://schemas.openxmlformats.org/presentationml/2006/main">
   <p:sldMasterIdLst>
-    <p:sldMasterId xmlns:r="http://schemas.openxmlformats.org/officeDocument/2006/relationships" id="2147483648" r:id="Rca1c3e7f04fb4c36"/>
+    <p:sldMasterId xmlns:r="http://schemas.openxmlformats.org/officeDocument/2006/relationships" id="2147483648" r:id="R1edf0923db7842b1"/>
   </p:sldMasterIdLst>
   <p:notesMasterIdLst>
-    <p:notesMasterId xmlns:r="http://schemas.openxmlformats.org/officeDocument/2006/relationships" r:id="R6bbad3cf5eb04cdb"/>
+    <p:notesMasterId xmlns:r="http://schemas.openxmlformats.org/officeDocument/2006/relationships" r:id="R03c8c7c6b4f048ee"/>
   </p:notesMasterIdLst>
   <p:sldIdLst>
-    <p:sldId xmlns:r="http://schemas.openxmlformats.org/officeDocument/2006/relationships" id="256" r:id="R51ce8e54d3cc4bd3"/>
-    <p:sldId xmlns:r="http://schemas.openxmlformats.org/officeDocument/2006/relationships" id="257" r:id="Rb06dda3a95db44d0"/>
-    <p:sldId xmlns:r="http://schemas.openxmlformats.org/officeDocument/2006/relationships" id="258" r:id="Rbd11728811f04478"/>
-    <p:sldId xmlns:r="http://schemas.openxmlformats.org/officeDocument/2006/relationships" id="259" r:id="Rcaf45316003c4e59"/>
-    <p:sldId xmlns:r="http://schemas.openxmlformats.org/officeDocument/2006/relationships" id="260" r:id="R8f4ddbe87e804aad"/>
-    <p:sldId xmlns:r="http://schemas.openxmlformats.org/officeDocument/2006/relationships" id="261" r:id="Rec9699e8585f46e7"/>
-    <p:sldId xmlns:r="http://schemas.openxmlformats.org/officeDocument/2006/relationships" id="262" r:id="R58762b74f97a4dc1"/>
-    <p:sldId xmlns:r="http://schemas.openxmlformats.org/officeDocument/2006/relationships" id="263" r:id="Rc5eacad3ea5044a6"/>
-    <p:sldId xmlns:r="http://schemas.openxmlformats.org/officeDocument/2006/relationships" id="264" r:id="R4e93c089b10c42c2"/>
-    <p:sldId xmlns:r="http://schemas.openxmlformats.org/officeDocument/2006/relationships" id="265" r:id="R8a9577fab89b4a7b"/>
-    <p:sldId xmlns:r="http://schemas.openxmlformats.org/officeDocument/2006/relationships" id="266" r:id="R439b10e466a7473c"/>
-    <p:sldId xmlns:r="http://schemas.openxmlformats.org/officeDocument/2006/relationships" id="267" r:id="Rc6cc03be0cc04ddf"/>
-    <p:sldId xmlns:r="http://schemas.openxmlformats.org/officeDocument/2006/relationships" id="268" r:id="Rc9fc92693dbb48db"/>
-    <p:sldId xmlns:r="http://schemas.openxmlformats.org/officeDocument/2006/relationships" id="269" r:id="R2d06b8d04a524329"/>
-    <p:sldId xmlns:r="http://schemas.openxmlformats.org/officeDocument/2006/relationships" id="270" r:id="Rf243debd32674c79"/>
-    <p:sldId xmlns:r="http://schemas.openxmlformats.org/officeDocument/2006/relationships" id="271" r:id="R9412633db5c84c6b"/>
-    <p:sldId xmlns:r="http://schemas.openxmlformats.org/officeDocument/2006/relationships" id="272" r:id="Ra5a486c1c984494d"/>
-    <p:sldId xmlns:r="http://schemas.openxmlformats.org/officeDocument/2006/relationships" id="273" r:id="Ra856378b2aea4db6"/>
-    <p:sldId xmlns:r="http://schemas.openxmlformats.org/officeDocument/2006/relationships" id="274" r:id="R46ce1a72ba774648"/>
-    <p:sldId xmlns:r="http://schemas.openxmlformats.org/officeDocument/2006/relationships" id="275" r:id="Rf04652c0a1cd4be6"/>
-    <p:sldId xmlns:r="http://schemas.openxmlformats.org/officeDocument/2006/relationships" id="276" r:id="Rb9a4e736749f41f7"/>
-    <p:sldId xmlns:r="http://schemas.openxmlformats.org/officeDocument/2006/relationships" id="277" r:id="R7873f0242f7f4f64"/>
-    <p:sldId xmlns:r="http://schemas.openxmlformats.org/officeDocument/2006/relationships" id="278" r:id="R2d04f0409ce94a1d"/>
-    <p:sldId xmlns:r="http://schemas.openxmlformats.org/officeDocument/2006/relationships" id="279" r:id="R21018c933b40407a"/>
+    <p:sldId xmlns:r="http://schemas.openxmlformats.org/officeDocument/2006/relationships" id="256" r:id="Rdbfa46c3686b4779"/>
+    <p:sldId xmlns:r="http://schemas.openxmlformats.org/officeDocument/2006/relationships" id="257" r:id="R206d5072d43b4814"/>
+    <p:sldId xmlns:r="http://schemas.openxmlformats.org/officeDocument/2006/relationships" id="258" r:id="R1c8a5103eb2e4258"/>
+    <p:sldId xmlns:r="http://schemas.openxmlformats.org/officeDocument/2006/relationships" id="259" r:id="Ra7c512f379ac4c73"/>
+    <p:sldId xmlns:r="http://schemas.openxmlformats.org/officeDocument/2006/relationships" id="260" r:id="R579cc56710c04d0b"/>
+    <p:sldId xmlns:r="http://schemas.openxmlformats.org/officeDocument/2006/relationships" id="261" r:id="Rc6113f0d5c354fea"/>
+    <p:sldId xmlns:r="http://schemas.openxmlformats.org/officeDocument/2006/relationships" id="262" r:id="R9bd4f7c391e14600"/>
+    <p:sldId xmlns:r="http://schemas.openxmlformats.org/officeDocument/2006/relationships" id="263" r:id="R269536d814724c84"/>
+    <p:sldId xmlns:r="http://schemas.openxmlformats.org/officeDocument/2006/relationships" id="264" r:id="R8b12e817ad5c4bb2"/>
+    <p:sldId xmlns:r="http://schemas.openxmlformats.org/officeDocument/2006/relationships" id="265" r:id="R849f2ae177ab4f1d"/>
+    <p:sldId xmlns:r="http://schemas.openxmlformats.org/officeDocument/2006/relationships" id="266" r:id="R46fb1cb1408c4cee"/>
+    <p:sldId xmlns:r="http://schemas.openxmlformats.org/officeDocument/2006/relationships" id="267" r:id="R148468cca1594935"/>
+    <p:sldId xmlns:r="http://schemas.openxmlformats.org/officeDocument/2006/relationships" id="268" r:id="Rcadb25722dcf46c7"/>
+    <p:sldId xmlns:r="http://schemas.openxmlformats.org/officeDocument/2006/relationships" id="269" r:id="R9a49157aa3094ce1"/>
+    <p:sldId xmlns:r="http://schemas.openxmlformats.org/officeDocument/2006/relationships" id="270" r:id="Re5b1206350344d04"/>
+    <p:sldId xmlns:r="http://schemas.openxmlformats.org/officeDocument/2006/relationships" id="271" r:id="R1f27efd134314fd9"/>
+    <p:sldId xmlns:r="http://schemas.openxmlformats.org/officeDocument/2006/relationships" id="272" r:id="R0c8a211bef5149e9"/>
+    <p:sldId xmlns:r="http://schemas.openxmlformats.org/officeDocument/2006/relationships" id="273" r:id="Rb97d6ece5bd54980"/>
+    <p:sldId xmlns:r="http://schemas.openxmlformats.org/officeDocument/2006/relationships" id="274" r:id="R3abd2cbb9b4f4796"/>
+    <p:sldId xmlns:r="http://schemas.openxmlformats.org/officeDocument/2006/relationships" id="275" r:id="R994758564fb54501"/>
+    <p:sldId xmlns:r="http://schemas.openxmlformats.org/officeDocument/2006/relationships" id="276" r:id="R36a43d7dba1541b2"/>
+    <p:sldId xmlns:r="http://schemas.openxmlformats.org/officeDocument/2006/relationships" id="277" r:id="R422360b7a403464e"/>
+    <p:sldId xmlns:r="http://schemas.openxmlformats.org/officeDocument/2006/relationships" id="278" r:id="R1d1be03ae4914d97"/>
+    <p:sldId xmlns:r="http://schemas.openxmlformats.org/officeDocument/2006/relationships" id="279" r:id="Ra873450bfd3f489b"/>
   </p:sldIdLst>
   <p:sldSz cx="12192000" cy="6858000"/>
   <p:notesSz cx="6858000" cy="9144000"/>
@@ -1410,7 +1410,7 @@
           </a:p>
           <a:p xmlns:a="http://schemas.openxmlformats.org/drawingml/2006/main">
             <a:r>
-              <a:t>AMAC 2026大模型应用规范为团体标准，提供场景评测和权限参考，具体采用依据仍需确认。美国SR26-2是银行监督指引，配套定义排除生成式和Agentic AI，不能代替MSIM内部政策。</a:t>
+              <a:t>AMAC 2026大模型应用规范为团体标准，提供场景评测和权限参考，具体采用依据仍需确认。美国SR26-2是银行监督指引，配套定义排除生成式和Agentic AI，不能代替机构内部政策。</a:t>
             </a:r>
           </a:p>
           <a:p xmlns:a="http://schemas.openxmlformats.org/drawingml/2006/main">
@@ -4813,7 +4813,7 @@
   </p:cSld>
   <p:clrMap bg1="lt1" tx1="dk1" bg2="lt2" tx2="dk2" accent1="accent1" accent2="accent2" accent3="accent3" accent4="accent4" accent5="accent5" accent6="accent6" hlink="hlink" folHlink="folHlink"/>
   <p:sldLayoutIdLst>
-    <p:sldLayoutId xmlns:r="http://schemas.openxmlformats.org/officeDocument/2006/relationships" id="2147483649" r:id="R6e3cbd959e4e4022"/>
+    <p:sldLayoutId xmlns:r="http://schemas.openxmlformats.org/officeDocument/2006/relationships" id="2147483649" r:id="R01a13e4032af4281"/>
   </p:sldLayoutIdLst>
   <p:txStyles>
     <p:titleStyle>
@@ -5341,7 +5341,7 @@
 </file>
 
 <file path=ppt/slides/charts/chart1.xml><?xml version="1.0" encoding="utf-8"?>
-<c:chartSpace xmlns:c="http://schemas.openxmlformats.org/drawingml/2006/chart" xmlns:r="http://schemas.openxmlformats.org/officeDocument/2006/relationships">
+<c:chartSpace xmlns:c="http://schemas.openxmlformats.org/drawingml/2006/chart">
   <c:lang val="en-US"/>
   <c:chart>
     <c:plotArea>
@@ -5593,14 +5593,14 @@
       <a:noFill/>
     </a:ln>
   </c:spPr>
-  <c:externalData r:id="rIdChartSnapshot1">
+  <c:externalData xmlns:r="http://schemas.openxmlformats.org/officeDocument/2006/relationships" r:id="rIdChartSnapshot1">
     <c:autoUpdate val="0"/>
   </c:externalData>
 </c:chartSpace>
 </file>
 
 <file path=ppt/slides/charts/chart2.xml><?xml version="1.0" encoding="utf-8"?>
-<c:chartSpace xmlns:c="http://schemas.openxmlformats.org/drawingml/2006/chart" xmlns:r="http://schemas.openxmlformats.org/officeDocument/2006/relationships">
+<c:chartSpace xmlns:c="http://schemas.openxmlformats.org/drawingml/2006/chart">
   <c:lang val="en-US"/>
   <c:chart>
     <c:plotArea>
@@ -5785,7 +5785,7 @@
       <a:noFill/>
     </a:ln>
   </c:spPr>
-  <c:externalData r:id="rIdChartSnapshot1">
+  <c:externalData xmlns:r="http://schemas.openxmlformats.org/officeDocument/2006/relationships" r:id="rIdChartSnapshot1">
     <c:autoUpdate val="0"/>
   </c:externalData>
 </c:chartSpace>
@@ -5844,6 +5844,7 @@
           <a:lstStyle xmlns:a="http://schemas.openxmlformats.org/drawingml/2006/main"/>
           <a:p xmlns:a="http://schemas.openxmlformats.org/drawingml/2006/main">
             <a:pPr algn="l">
+              <a:buNone/>
               <a:defRPr sz="4800" b="1">
                 <a:solidFill>
                   <a:srgbClr val="FFFFFF"/>
@@ -5901,6 +5902,7 @@
           <a:lstStyle xmlns:a="http://schemas.openxmlformats.org/drawingml/2006/main"/>
           <a:p xmlns:a="http://schemas.openxmlformats.org/drawingml/2006/main">
             <a:pPr algn="l">
+              <a:buNone/>
               <a:defRPr sz="2550" b="0">
                 <a:solidFill>
                   <a:srgbClr val="B7DDDA"/>
@@ -5926,7 +5928,7 @@
       </p:sp>
       <p:sp>
         <p:nvSpPr>
-          <p:cNvPr id="3" name="text-4iuov6-MSIM China 实习项目">
+          <p:cNvPr id="3" name="text-4iuov6-Intern 实习项目">
             <a:extLst xmlns:a="http://schemas.openxmlformats.org/drawingml/2006/main">
               <a:ext uri="{FF2B5EF4-FFF2-40B4-BE49-F238E27FC236}">
                 <a16:creationId xmlns:a16="http://schemas.microsoft.com/office/drawing/2014/main" id="{5BFB0230-67C4-4CE3-ABC7-ED3B36216608}"/>
@@ -5958,6 +5960,7 @@
           <a:lstStyle xmlns:a="http://schemas.openxmlformats.org/drawingml/2006/main"/>
           <a:p xmlns:a="http://schemas.openxmlformats.org/drawingml/2006/main">
             <a:pPr algn="l">
+              <a:buNone/>
               <a:defRPr sz="1875" b="0">
                 <a:solidFill>
                   <a:srgbClr val="FFFFFF"/>
@@ -5976,7 +5979,18 @@
                 <a:ea typeface="Heiti SC"/>
                 <a:cs typeface="Heiti SC"/>
               </a:rPr>
-              <a:t>MSIM China 实习项目</a:t>
+              <a:t>Intern</a:t>
+            </a:r>
+            <a:r>
+              <a:rPr sz="1875" b="0">
+                <a:solidFill>
+                  <a:srgbClr val="FFFFFF"/>
+                </a:solidFill>
+                <a:latin typeface="Heiti SC"/>
+                <a:ea typeface="Heiti SC"/>
+                <a:cs typeface="Heiti SC"/>
+              </a:rPr>
+              <a:t> 实习项目</a:t>
             </a:r>
           </a:p>
         </p:txBody>
@@ -6015,6 +6029,7 @@
           <a:lstStyle xmlns:a="http://schemas.openxmlformats.org/drawingml/2006/main"/>
           <a:p xmlns:a="http://schemas.openxmlformats.org/drawingml/2006/main">
             <a:pPr algn="l">
+              <a:buNone/>
               <a:defRPr sz="1650" b="0">
                 <a:solidFill>
                   <a:srgbClr val="C7D5DD"/>
@@ -6101,6 +6116,7 @@
           <a:lstStyle xmlns:a="http://schemas.openxmlformats.org/drawingml/2006/main"/>
           <a:p xmlns:a="http://schemas.openxmlformats.org/drawingml/2006/main">
             <a:pPr algn="l">
+              <a:buNone/>
               <a:defRPr sz="3300" b="1">
                 <a:solidFill>
                   <a:srgbClr val="19374D"/>
@@ -6158,6 +6174,7 @@
           <a:lstStyle xmlns:a="http://schemas.openxmlformats.org/drawingml/2006/main"/>
           <a:p xmlns:a="http://schemas.openxmlformats.org/drawingml/2006/main">
             <a:pPr algn="l">
+              <a:buNone/>
               <a:defRPr sz="1500" b="0">
                 <a:solidFill>
                   <a:srgbClr val="566975"/>
@@ -6215,6 +6232,7 @@
           <a:lstStyle xmlns:a="http://schemas.openxmlformats.org/drawingml/2006/main"/>
           <a:p xmlns:a="http://schemas.openxmlformats.org/drawingml/2006/main">
             <a:pPr algn="r">
+              <a:buNone/>
               <a:defRPr sz="1275" b="0">
                 <a:solidFill>
                   <a:srgbClr val="566975"/>
@@ -6240,7 +6258,7 @@
       </p:sp>
       <p:graphicFrame>
         <p:nvGraphicFramePr>
-          <p:cNvPr id="8" name=""/>
+          <p:cNvPr id="10" name=""/>
           <p:cNvGraphicFramePr/>
           <p:nvPr/>
         </p:nvGraphicFramePr>
@@ -6620,6 +6638,7 @@
           <a:lstStyle xmlns:a="http://schemas.openxmlformats.org/drawingml/2006/main"/>
           <a:p xmlns:a="http://schemas.openxmlformats.org/drawingml/2006/main">
             <a:pPr algn="l">
+              <a:buNone/>
               <a:defRPr sz="3300" b="1">
                 <a:solidFill>
                   <a:srgbClr val="19374D"/>
@@ -6677,6 +6696,7 @@
           <a:lstStyle xmlns:a="http://schemas.openxmlformats.org/drawingml/2006/main"/>
           <a:p xmlns:a="http://schemas.openxmlformats.org/drawingml/2006/main">
             <a:pPr algn="l">
+              <a:buNone/>
               <a:defRPr sz="1950" b="0">
                 <a:solidFill>
                   <a:srgbClr val="566975"/>
@@ -6734,6 +6754,7 @@
           <a:lstStyle xmlns:a="http://schemas.openxmlformats.org/drawingml/2006/main"/>
           <a:p xmlns:a="http://schemas.openxmlformats.org/drawingml/2006/main">
             <a:pPr algn="r">
+              <a:buNone/>
               <a:defRPr sz="1275" b="0">
                 <a:solidFill>
                   <a:srgbClr val="566975"/>
@@ -6759,7 +6780,7 @@
       </p:sp>
       <p:graphicFrame>
         <p:nvGraphicFramePr>
-          <p:cNvPr id="9" name=""/>
+          <p:cNvPr id="11" name=""/>
           <p:cNvGraphicFramePr/>
           <p:nvPr/>
         </p:nvGraphicFramePr>
@@ -7063,6 +7084,7 @@
           <a:lstStyle xmlns:a="http://schemas.openxmlformats.org/drawingml/2006/main"/>
           <a:p xmlns:a="http://schemas.openxmlformats.org/drawingml/2006/main">
             <a:pPr algn="l">
+              <a:buNone/>
               <a:defRPr sz="2175" b="0">
                 <a:solidFill>
                   <a:srgbClr val="008C83"/>
@@ -7149,6 +7171,7 @@
           <a:lstStyle xmlns:a="http://schemas.openxmlformats.org/drawingml/2006/main"/>
           <a:p xmlns:a="http://schemas.openxmlformats.org/drawingml/2006/main">
             <a:pPr algn="l">
+              <a:buNone/>
               <a:defRPr sz="3300" b="1">
                 <a:solidFill>
                   <a:srgbClr val="19374D"/>
@@ -7206,6 +7229,7 @@
           <a:lstStyle xmlns:a="http://schemas.openxmlformats.org/drawingml/2006/main"/>
           <a:p xmlns:a="http://schemas.openxmlformats.org/drawingml/2006/main">
             <a:pPr algn="l">
+              <a:buNone/>
               <a:defRPr sz="1950" b="0">
                 <a:solidFill>
                   <a:srgbClr val="566975"/>
@@ -7263,6 +7287,7 @@
           <a:lstStyle xmlns:a="http://schemas.openxmlformats.org/drawingml/2006/main"/>
           <a:p xmlns:a="http://schemas.openxmlformats.org/drawingml/2006/main">
             <a:pPr algn="l">
+              <a:buNone/>
               <a:defRPr sz="1500" b="0">
                 <a:solidFill>
                   <a:srgbClr val="566975"/>
@@ -7320,6 +7345,7 @@
           <a:lstStyle xmlns:a="http://schemas.openxmlformats.org/drawingml/2006/main"/>
           <a:p xmlns:a="http://schemas.openxmlformats.org/drawingml/2006/main">
             <a:pPr algn="r">
+              <a:buNone/>
               <a:defRPr sz="1275" b="0">
                 <a:solidFill>
                   <a:srgbClr val="566975"/>
@@ -7345,7 +7371,7 @@
       </p:sp>
       <p:graphicFrame>
         <p:nvGraphicFramePr>
-          <p:cNvPr id="12" name="Chart"/>
+          <p:cNvPr id="14" name="Chart"/>
           <p:cNvGraphicFramePr/>
           <p:nvPr/>
         </p:nvGraphicFramePr>
@@ -7355,7 +7381,7 @@
         </p:xfrm>
         <a:graphic xmlns:a="http://schemas.openxmlformats.org/drawingml/2006/main">
           <a:graphicData uri="http://schemas.openxmlformats.org/drawingml/2006/chart">
-            <c:chart xmlns:r="http://schemas.openxmlformats.org/officeDocument/2006/relationships" xmlns:c="http://schemas.openxmlformats.org/drawingml/2006/chart" r:id="Rd7eedf17f2584f92"/>
+            <c:chart xmlns:r="http://schemas.openxmlformats.org/officeDocument/2006/relationships" xmlns:c="http://schemas.openxmlformats.org/drawingml/2006/chart" r:id="Rf550f1e76d504501"/>
           </a:graphicData>
         </a:graphic>
       </p:graphicFrame>
@@ -7393,6 +7419,7 @@
           <a:lstStyle xmlns:a="http://schemas.openxmlformats.org/drawingml/2006/main"/>
           <a:p xmlns:a="http://schemas.openxmlformats.org/drawingml/2006/main">
             <a:pPr algn="l">
+              <a:buNone/>
               <a:defRPr sz="2250" b="1">
                 <a:solidFill>
                   <a:srgbClr val="19374D"/>
@@ -7416,6 +7443,7 @@
           </a:p>
           <a:p xmlns:a="http://schemas.openxmlformats.org/drawingml/2006/main">
             <a:pPr algn="l">
+              <a:buNone/>
               <a:defRPr sz="2250" b="1">
                 <a:solidFill>
                   <a:srgbClr val="19374D"/>
@@ -7473,6 +7501,7 @@
           <a:lstStyle xmlns:a="http://schemas.openxmlformats.org/drawingml/2006/main"/>
           <a:p xmlns:a="http://schemas.openxmlformats.org/drawingml/2006/main">
             <a:pPr algn="l">
+              <a:buNone/>
               <a:defRPr sz="2025" b="0">
                 <a:solidFill>
                   <a:srgbClr val="253C4A"/>
@@ -7496,6 +7525,7 @@
           </a:p>
           <a:p xmlns:a="http://schemas.openxmlformats.org/drawingml/2006/main">
             <a:pPr algn="l">
+              <a:buNone/>
               <a:defRPr sz="2025" b="0">
                 <a:solidFill>
                   <a:srgbClr val="253C4A"/>
@@ -7519,6 +7549,7 @@
           </a:p>
           <a:p xmlns:a="http://schemas.openxmlformats.org/drawingml/2006/main">
             <a:pPr algn="l">
+              <a:buNone/>
               <a:defRPr sz="2025" b="0">
                 <a:solidFill>
                   <a:srgbClr val="253C4A"/>
@@ -7605,6 +7636,7 @@
           <a:lstStyle xmlns:a="http://schemas.openxmlformats.org/drawingml/2006/main"/>
           <a:p xmlns:a="http://schemas.openxmlformats.org/drawingml/2006/main">
             <a:pPr algn="l">
+              <a:buNone/>
               <a:defRPr sz="3300" b="1">
                 <a:solidFill>
                   <a:srgbClr val="19374D"/>
@@ -7662,6 +7694,7 @@
           <a:lstStyle xmlns:a="http://schemas.openxmlformats.org/drawingml/2006/main"/>
           <a:p xmlns:a="http://schemas.openxmlformats.org/drawingml/2006/main">
             <a:pPr algn="l">
+              <a:buNone/>
               <a:defRPr sz="1950" b="0">
                 <a:solidFill>
                   <a:srgbClr val="566975"/>
@@ -7719,6 +7752,7 @@
           <a:lstStyle xmlns:a="http://schemas.openxmlformats.org/drawingml/2006/main"/>
           <a:p xmlns:a="http://schemas.openxmlformats.org/drawingml/2006/main">
             <a:pPr algn="l">
+              <a:buNone/>
               <a:defRPr sz="1500" b="0">
                 <a:solidFill>
                   <a:srgbClr val="566975"/>
@@ -7776,6 +7810,7 @@
           <a:lstStyle xmlns:a="http://schemas.openxmlformats.org/drawingml/2006/main"/>
           <a:p xmlns:a="http://schemas.openxmlformats.org/drawingml/2006/main">
             <a:pPr algn="r">
+              <a:buNone/>
               <a:defRPr sz="1275" b="0">
                 <a:solidFill>
                   <a:srgbClr val="566975"/>
@@ -7833,6 +7868,7 @@
           <a:lstStyle xmlns:a="http://schemas.openxmlformats.org/drawingml/2006/main"/>
           <a:p xmlns:a="http://schemas.openxmlformats.org/drawingml/2006/main">
             <a:pPr algn="l">
+              <a:buNone/>
               <a:defRPr sz="2250" b="0">
                 <a:solidFill>
                   <a:srgbClr val="253C4A"/>
@@ -7856,6 +7892,7 @@
           </a:p>
           <a:p xmlns:a="http://schemas.openxmlformats.org/drawingml/2006/main">
             <a:pPr algn="l">
+              <a:buNone/>
               <a:defRPr sz="2250" b="0">
                 <a:solidFill>
                   <a:srgbClr val="253C4A"/>
@@ -7881,7 +7918,7 @@
       </p:sp>
       <p:graphicFrame>
         <p:nvGraphicFramePr>
-          <p:cNvPr id="13" name=""/>
+          <p:cNvPr id="15" name=""/>
           <p:cNvGraphicFramePr/>
           <p:nvPr/>
         </p:nvGraphicFramePr>
@@ -8158,6 +8195,7 @@
           <a:lstStyle xmlns:a="http://schemas.openxmlformats.org/drawingml/2006/main"/>
           <a:p xmlns:a="http://schemas.openxmlformats.org/drawingml/2006/main">
             <a:pPr algn="l">
+              <a:buNone/>
               <a:defRPr sz="2175" b="0">
                 <a:solidFill>
                   <a:srgbClr val="008C83"/>
@@ -8244,6 +8282,7 @@
           <a:lstStyle xmlns:a="http://schemas.openxmlformats.org/drawingml/2006/main"/>
           <a:p xmlns:a="http://schemas.openxmlformats.org/drawingml/2006/main">
             <a:pPr algn="l">
+              <a:buNone/>
               <a:defRPr sz="3300" b="1">
                 <a:solidFill>
                   <a:srgbClr val="19374D"/>
@@ -8301,6 +8340,7 @@
           <a:lstStyle xmlns:a="http://schemas.openxmlformats.org/drawingml/2006/main"/>
           <a:p xmlns:a="http://schemas.openxmlformats.org/drawingml/2006/main">
             <a:pPr algn="l">
+              <a:buNone/>
               <a:defRPr sz="1950" b="0">
                 <a:solidFill>
                   <a:srgbClr val="566975"/>
@@ -8358,6 +8398,7 @@
           <a:lstStyle xmlns:a="http://schemas.openxmlformats.org/drawingml/2006/main"/>
           <a:p xmlns:a="http://schemas.openxmlformats.org/drawingml/2006/main">
             <a:pPr algn="l">
+              <a:buNone/>
               <a:defRPr sz="1500" b="0">
                 <a:solidFill>
                   <a:srgbClr val="566975"/>
@@ -8381,6 +8422,7 @@
           </a:p>
           <a:p xmlns:a="http://schemas.openxmlformats.org/drawingml/2006/main">
             <a:pPr algn="l">
+              <a:buNone/>
               <a:defRPr sz="1500" b="0">
                 <a:solidFill>
                   <a:srgbClr val="566975"/>
@@ -8438,6 +8480,7 @@
           <a:lstStyle xmlns:a="http://schemas.openxmlformats.org/drawingml/2006/main"/>
           <a:p xmlns:a="http://schemas.openxmlformats.org/drawingml/2006/main">
             <a:pPr algn="r">
+              <a:buNone/>
               <a:defRPr sz="1275" b="0">
                 <a:solidFill>
                   <a:srgbClr val="566975"/>
@@ -8463,7 +8506,7 @@
       </p:sp>
       <p:graphicFrame>
         <p:nvGraphicFramePr>
-          <p:cNvPr id="11" name="Chart"/>
+          <p:cNvPr id="14" name="Chart"/>
           <p:cNvGraphicFramePr/>
           <p:nvPr/>
         </p:nvGraphicFramePr>
@@ -8473,13 +8516,13 @@
         </p:xfrm>
         <a:graphic xmlns:a="http://schemas.openxmlformats.org/drawingml/2006/main">
           <a:graphicData uri="http://schemas.openxmlformats.org/drawingml/2006/chart">
-            <c:chart xmlns:r="http://schemas.openxmlformats.org/officeDocument/2006/relationships" xmlns:c="http://schemas.openxmlformats.org/drawingml/2006/chart" r:id="Rac3a4ab1ac4b43a2"/>
+            <c:chart xmlns:r="http://schemas.openxmlformats.org/officeDocument/2006/relationships" xmlns:c="http://schemas.openxmlformats.org/drawingml/2006/chart" r:id="R6579275dbdae4211"/>
           </a:graphicData>
         </a:graphic>
       </p:graphicFrame>
       <p:graphicFrame>
         <p:nvGraphicFramePr>
-          <p:cNvPr id="12" name=""/>
+          <p:cNvPr id="15" name=""/>
           <p:cNvGraphicFramePr/>
           <p:nvPr/>
         </p:nvGraphicFramePr>
@@ -8775,6 +8818,7 @@
           <a:lstStyle xmlns:a="http://schemas.openxmlformats.org/drawingml/2006/main"/>
           <a:p xmlns:a="http://schemas.openxmlformats.org/drawingml/2006/main">
             <a:pPr algn="l">
+              <a:buNone/>
               <a:defRPr sz="3300" b="1">
                 <a:solidFill>
                   <a:srgbClr val="19374D"/>
@@ -8832,6 +8876,7 @@
           <a:lstStyle xmlns:a="http://schemas.openxmlformats.org/drawingml/2006/main"/>
           <a:p xmlns:a="http://schemas.openxmlformats.org/drawingml/2006/main">
             <a:pPr algn="r">
+              <a:buNone/>
               <a:defRPr sz="1275" b="0">
                 <a:solidFill>
                   <a:srgbClr val="566975"/>
@@ -8857,7 +8902,7 @@
       </p:sp>
       <p:graphicFrame>
         <p:nvGraphicFramePr>
-          <p:cNvPr id="7" name=""/>
+          <p:cNvPr id="9" name=""/>
           <p:cNvGraphicFramePr/>
           <p:nvPr/>
         </p:nvGraphicFramePr>
@@ -9208,6 +9253,7 @@
           <a:lstStyle xmlns:a="http://schemas.openxmlformats.org/drawingml/2006/main"/>
           <a:p xmlns:a="http://schemas.openxmlformats.org/drawingml/2006/main">
             <a:pPr algn="l">
+              <a:buNone/>
               <a:defRPr sz="2175" b="0">
                 <a:solidFill>
                   <a:srgbClr val="008C83"/>
@@ -9294,6 +9340,7 @@
           <a:lstStyle xmlns:a="http://schemas.openxmlformats.org/drawingml/2006/main"/>
           <a:p xmlns:a="http://schemas.openxmlformats.org/drawingml/2006/main">
             <a:pPr algn="l">
+              <a:buNone/>
               <a:defRPr sz="3300" b="1">
                 <a:solidFill>
                   <a:srgbClr val="19374D"/>
@@ -9319,7 +9366,7 @@
       </p:sp>
       <p:sp>
         <p:nvSpPr>
-          <p:cNvPr id="2" name="text-pmketg-公开文件提供研究依据。MSIM内">
+          <p:cNvPr id="2" name="text-pmketg-公开文件提供研究依据。机构内">
             <a:extLst xmlns:a="http://schemas.openxmlformats.org/drawingml/2006/main">
               <a:ext uri="{FF2B5EF4-FFF2-40B4-BE49-F238E27FC236}">
                 <a16:creationId xmlns:a16="http://schemas.microsoft.com/office/drawing/2014/main" id="{3C97F5AB-3856-4A09-B0EE-F1795A3A03B7}"/>
@@ -9351,6 +9398,7 @@
           <a:lstStyle xmlns:a="http://schemas.openxmlformats.org/drawingml/2006/main"/>
           <a:p xmlns:a="http://schemas.openxmlformats.org/drawingml/2006/main">
             <a:pPr algn="l">
+              <a:buNone/>
               <a:defRPr sz="1500" b="0">
                 <a:solidFill>
                   <a:srgbClr val="566975"/>
@@ -9369,7 +9417,29 @@
                 <a:ea typeface="Heiti SC"/>
                 <a:cs typeface="Heiti SC"/>
               </a:rPr>
-              <a:t>公开文件提供研究依据。MSIM内部制度、COD条件和具体用例分类仍需确认。</a:t>
+              <a:t>公开文件提供研究依据。</a:t>
+            </a:r>
+            <a:r>
+              <a:rPr sz="1500" b="0">
+                <a:solidFill>
+                  <a:srgbClr val="566975"/>
+                </a:solidFill>
+                <a:latin typeface="Heiti SC"/>
+                <a:ea typeface="Heiti SC"/>
+                <a:cs typeface="Heiti SC"/>
+              </a:rPr>
+              <a:t>机构</a:t>
+            </a:r>
+            <a:r>
+              <a:rPr sz="1500" b="0">
+                <a:solidFill>
+                  <a:srgbClr val="566975"/>
+                </a:solidFill>
+                <a:latin typeface="Heiti SC"/>
+                <a:ea typeface="Heiti SC"/>
+                <a:cs typeface="Heiti SC"/>
+              </a:rPr>
+              <a:t>内部制度、COD条件和具体用例分类仍需确认。</a:t>
             </a:r>
           </a:p>
         </p:txBody>
@@ -9408,6 +9478,7 @@
           <a:lstStyle xmlns:a="http://schemas.openxmlformats.org/drawingml/2006/main"/>
           <a:p xmlns:a="http://schemas.openxmlformats.org/drawingml/2006/main">
             <a:pPr algn="r">
+              <a:buNone/>
               <a:defRPr sz="1275" b="0">
                 <a:solidFill>
                   <a:srgbClr val="566975"/>
@@ -9433,7 +9504,7 @@
       </p:sp>
       <p:graphicFrame>
         <p:nvGraphicFramePr>
-          <p:cNvPr id="8" name=""/>
+          <p:cNvPr id="10" name=""/>
           <p:cNvGraphicFramePr/>
           <p:nvPr/>
         </p:nvGraphicFramePr>
@@ -9826,6 +9897,7 @@
           <a:lstStyle xmlns:a="http://schemas.openxmlformats.org/drawingml/2006/main"/>
           <a:p xmlns:a="http://schemas.openxmlformats.org/drawingml/2006/main">
             <a:pPr algn="l">
+              <a:buNone/>
               <a:defRPr sz="3300" b="1">
                 <a:solidFill>
                   <a:srgbClr val="19374D"/>
@@ -9883,6 +9955,7 @@
           <a:lstStyle xmlns:a="http://schemas.openxmlformats.org/drawingml/2006/main"/>
           <a:p xmlns:a="http://schemas.openxmlformats.org/drawingml/2006/main">
             <a:pPr algn="r">
+              <a:buNone/>
               <a:defRPr sz="1275" b="0">
                 <a:solidFill>
                   <a:srgbClr val="566975"/>
@@ -9908,7 +9981,7 @@
       </p:sp>
       <p:graphicFrame>
         <p:nvGraphicFramePr>
-          <p:cNvPr id="6" name=""/>
+          <p:cNvPr id="8" name=""/>
           <p:cNvGraphicFramePr/>
           <p:nvPr/>
         </p:nvGraphicFramePr>
@@ -10241,6 +10314,7 @@
           <a:lstStyle xmlns:a="http://schemas.openxmlformats.org/drawingml/2006/main"/>
           <a:p xmlns:a="http://schemas.openxmlformats.org/drawingml/2006/main">
             <a:pPr algn="l">
+              <a:buNone/>
               <a:defRPr sz="3300" b="1">
                 <a:solidFill>
                   <a:srgbClr val="19374D"/>
@@ -10298,6 +10372,7 @@
           <a:lstStyle xmlns:a="http://schemas.openxmlformats.org/drawingml/2006/main"/>
           <a:p xmlns:a="http://schemas.openxmlformats.org/drawingml/2006/main">
             <a:pPr algn="r">
+              <a:buNone/>
               <a:defRPr sz="1275" b="0">
                 <a:solidFill>
                   <a:srgbClr val="566975"/>
@@ -10323,7 +10398,7 @@
       </p:sp>
       <p:graphicFrame>
         <p:nvGraphicFramePr>
-          <p:cNvPr id="8" name=""/>
+          <p:cNvPr id="10" name=""/>
           <p:cNvGraphicFramePr/>
           <p:nvPr/>
         </p:nvGraphicFramePr>
@@ -10600,6 +10675,7 @@
           <a:lstStyle xmlns:a="http://schemas.openxmlformats.org/drawingml/2006/main"/>
           <a:p xmlns:a="http://schemas.openxmlformats.org/drawingml/2006/main">
             <a:pPr algn="l">
+              <a:buNone/>
               <a:defRPr sz="2400" b="1">
                 <a:solidFill>
                   <a:srgbClr val="008C83"/>
@@ -10657,6 +10733,7 @@
           <a:lstStyle xmlns:a="http://schemas.openxmlformats.org/drawingml/2006/main"/>
           <a:p xmlns:a="http://schemas.openxmlformats.org/drawingml/2006/main">
             <a:pPr algn="l">
+              <a:buNone/>
               <a:defRPr sz="2025" b="0">
                 <a:solidFill>
                   <a:srgbClr val="253C4A"/>
@@ -10743,6 +10820,7 @@
           <a:lstStyle xmlns:a="http://schemas.openxmlformats.org/drawingml/2006/main"/>
           <a:p xmlns:a="http://schemas.openxmlformats.org/drawingml/2006/main">
             <a:pPr algn="l">
+              <a:buNone/>
               <a:defRPr sz="3300" b="1">
                 <a:solidFill>
                   <a:srgbClr val="19374D"/>
@@ -10800,6 +10878,7 @@
           <a:lstStyle xmlns:a="http://schemas.openxmlformats.org/drawingml/2006/main"/>
           <a:p xmlns:a="http://schemas.openxmlformats.org/drawingml/2006/main">
             <a:pPr algn="l">
+              <a:buNone/>
               <a:defRPr sz="1500" b="0">
                 <a:solidFill>
                   <a:srgbClr val="566975"/>
@@ -10857,6 +10936,7 @@
           <a:lstStyle xmlns:a="http://schemas.openxmlformats.org/drawingml/2006/main"/>
           <a:p xmlns:a="http://schemas.openxmlformats.org/drawingml/2006/main">
             <a:pPr algn="r">
+              <a:buNone/>
               <a:defRPr sz="1275" b="0">
                 <a:solidFill>
                   <a:srgbClr val="566975"/>
@@ -10882,7 +10962,7 @@
       </p:sp>
       <p:graphicFrame>
         <p:nvGraphicFramePr>
-          <p:cNvPr id="8" name=""/>
+          <p:cNvPr id="10" name=""/>
           <p:cNvGraphicFramePr/>
           <p:nvPr/>
         </p:nvGraphicFramePr>
@@ -11944,6 +12024,7 @@
           <a:lstStyle xmlns:a="http://schemas.openxmlformats.org/drawingml/2006/main"/>
           <a:p xmlns:a="http://schemas.openxmlformats.org/drawingml/2006/main">
             <a:pPr algn="l">
+              <a:buNone/>
               <a:defRPr sz="3300" b="1">
                 <a:solidFill>
                   <a:srgbClr val="19374D"/>
@@ -12001,6 +12082,7 @@
           <a:lstStyle xmlns:a="http://schemas.openxmlformats.org/drawingml/2006/main"/>
           <a:p xmlns:a="http://schemas.openxmlformats.org/drawingml/2006/main">
             <a:pPr algn="r">
+              <a:buNone/>
               <a:defRPr sz="1275" b="0">
                 <a:solidFill>
                   <a:srgbClr val="566975"/>
@@ -12058,6 +12140,7 @@
           <a:lstStyle xmlns:a="http://schemas.openxmlformats.org/drawingml/2006/main"/>
           <a:p xmlns:a="http://schemas.openxmlformats.org/drawingml/2006/main">
             <a:pPr algn="l">
+              <a:buNone/>
               <a:defRPr sz="2850" b="1">
                 <a:solidFill>
                   <a:srgbClr val="008C83"/>
@@ -12115,6 +12198,7 @@
           <a:lstStyle xmlns:a="http://schemas.openxmlformats.org/drawingml/2006/main"/>
           <a:p xmlns:a="http://schemas.openxmlformats.org/drawingml/2006/main">
             <a:pPr algn="l">
+              <a:buNone/>
               <a:defRPr sz="2400" b="0">
                 <a:solidFill>
                   <a:srgbClr val="253C4A"/>
@@ -12138,6 +12222,7 @@
           </a:p>
           <a:p xmlns:a="http://schemas.openxmlformats.org/drawingml/2006/main">
             <a:pPr algn="l">
+              <a:buNone/>
               <a:defRPr sz="2400" b="0">
                 <a:solidFill>
                   <a:srgbClr val="253C4A"/>
@@ -12195,6 +12280,7 @@
           <a:lstStyle xmlns:a="http://schemas.openxmlformats.org/drawingml/2006/main"/>
           <a:p xmlns:a="http://schemas.openxmlformats.org/drawingml/2006/main">
             <a:pPr algn="l">
+              <a:buNone/>
               <a:defRPr sz="2400" b="0">
                 <a:solidFill>
                   <a:srgbClr val="253C4A"/>
@@ -12218,6 +12304,7 @@
           </a:p>
           <a:p xmlns:a="http://schemas.openxmlformats.org/drawingml/2006/main">
             <a:pPr algn="l">
+              <a:buNone/>
               <a:defRPr sz="2400" b="0">
                 <a:solidFill>
                   <a:srgbClr val="253C4A"/>
@@ -12304,6 +12391,7 @@
           <a:lstStyle xmlns:a="http://schemas.openxmlformats.org/drawingml/2006/main"/>
           <a:p xmlns:a="http://schemas.openxmlformats.org/drawingml/2006/main">
             <a:pPr algn="l">
+              <a:buNone/>
               <a:defRPr sz="3300" b="1">
                 <a:solidFill>
                   <a:srgbClr val="19374D"/>
@@ -12361,6 +12449,7 @@
           <a:lstStyle xmlns:a="http://schemas.openxmlformats.org/drawingml/2006/main"/>
           <a:p xmlns:a="http://schemas.openxmlformats.org/drawingml/2006/main">
             <a:pPr algn="l">
+              <a:buNone/>
               <a:defRPr sz="1500" b="0">
                 <a:solidFill>
                   <a:srgbClr val="566975"/>
@@ -12418,6 +12507,7 @@
           <a:lstStyle xmlns:a="http://schemas.openxmlformats.org/drawingml/2006/main"/>
           <a:p xmlns:a="http://schemas.openxmlformats.org/drawingml/2006/main">
             <a:pPr algn="r">
+              <a:buNone/>
               <a:defRPr sz="1275" b="0">
                 <a:solidFill>
                   <a:srgbClr val="566975"/>
@@ -12443,7 +12533,7 @@
       </p:sp>
       <p:graphicFrame>
         <p:nvGraphicFramePr>
-          <p:cNvPr id="8" name=""/>
+          <p:cNvPr id="10" name=""/>
           <p:cNvGraphicFramePr/>
           <p:nvPr/>
         </p:nvGraphicFramePr>
@@ -13544,6 +13634,7 @@
           <a:lstStyle xmlns:a="http://schemas.openxmlformats.org/drawingml/2006/main"/>
           <a:p xmlns:a="http://schemas.openxmlformats.org/drawingml/2006/main">
             <a:pPr algn="l">
+              <a:buNone/>
               <a:defRPr sz="3300" b="1">
                 <a:solidFill>
                   <a:srgbClr val="19374D"/>
@@ -13601,6 +13692,7 @@
           <a:lstStyle xmlns:a="http://schemas.openxmlformats.org/drawingml/2006/main"/>
           <a:p xmlns:a="http://schemas.openxmlformats.org/drawingml/2006/main">
             <a:pPr algn="l">
+              <a:buNone/>
               <a:defRPr sz="1500" b="0">
                 <a:solidFill>
                   <a:srgbClr val="566975"/>
@@ -13658,6 +13750,7 @@
           <a:lstStyle xmlns:a="http://schemas.openxmlformats.org/drawingml/2006/main"/>
           <a:p xmlns:a="http://schemas.openxmlformats.org/drawingml/2006/main">
             <a:pPr algn="r">
+              <a:buNone/>
               <a:defRPr sz="1275" b="0">
                 <a:solidFill>
                   <a:srgbClr val="566975"/>
@@ -13683,7 +13776,7 @@
       </p:sp>
       <p:graphicFrame>
         <p:nvGraphicFramePr>
-          <p:cNvPr id="8" name=""/>
+          <p:cNvPr id="10" name=""/>
           <p:cNvGraphicFramePr/>
           <p:nvPr/>
         </p:nvGraphicFramePr>
@@ -14745,6 +14838,7 @@
           <a:lstStyle xmlns:a="http://schemas.openxmlformats.org/drawingml/2006/main"/>
           <a:p xmlns:a="http://schemas.openxmlformats.org/drawingml/2006/main">
             <a:pPr algn="l">
+              <a:buNone/>
               <a:defRPr sz="3300" b="1">
                 <a:solidFill>
                   <a:srgbClr val="19374D"/>
@@ -14802,6 +14896,7 @@
           <a:lstStyle xmlns:a="http://schemas.openxmlformats.org/drawingml/2006/main"/>
           <a:p xmlns:a="http://schemas.openxmlformats.org/drawingml/2006/main">
             <a:pPr algn="l">
+              <a:buNone/>
               <a:defRPr sz="1950" b="0">
                 <a:solidFill>
                   <a:srgbClr val="566975"/>
@@ -14859,6 +14954,7 @@
           <a:lstStyle xmlns:a="http://schemas.openxmlformats.org/drawingml/2006/main"/>
           <a:p xmlns:a="http://schemas.openxmlformats.org/drawingml/2006/main">
             <a:pPr algn="l">
+              <a:buNone/>
               <a:defRPr sz="1500" b="0">
                 <a:solidFill>
                   <a:srgbClr val="566975"/>
@@ -14916,6 +15012,7 @@
           <a:lstStyle xmlns:a="http://schemas.openxmlformats.org/drawingml/2006/main"/>
           <a:p xmlns:a="http://schemas.openxmlformats.org/drawingml/2006/main">
             <a:pPr algn="r">
+              <a:buNone/>
               <a:defRPr sz="1275" b="0">
                 <a:solidFill>
                   <a:srgbClr val="566975"/>
@@ -14941,7 +15038,7 @@
       </p:sp>
       <p:graphicFrame>
         <p:nvGraphicFramePr>
-          <p:cNvPr id="11" name=""/>
+          <p:cNvPr id="13" name=""/>
           <p:cNvGraphicFramePr/>
           <p:nvPr/>
         </p:nvGraphicFramePr>
@@ -15526,6 +15623,7 @@
           <a:lstStyle xmlns:a="http://schemas.openxmlformats.org/drawingml/2006/main"/>
           <a:p xmlns:a="http://schemas.openxmlformats.org/drawingml/2006/main">
             <a:pPr algn="l">
+              <a:buNone/>
               <a:defRPr sz="2175" b="0">
                 <a:solidFill>
                   <a:srgbClr val="008C83"/>
@@ -15612,6 +15710,7 @@
           <a:lstStyle xmlns:a="http://schemas.openxmlformats.org/drawingml/2006/main"/>
           <a:p xmlns:a="http://schemas.openxmlformats.org/drawingml/2006/main">
             <a:pPr algn="l">
+              <a:buNone/>
               <a:defRPr sz="3300" b="1">
                 <a:solidFill>
                   <a:srgbClr val="19374D"/>
@@ -15669,6 +15768,7 @@
           <a:lstStyle xmlns:a="http://schemas.openxmlformats.org/drawingml/2006/main"/>
           <a:p xmlns:a="http://schemas.openxmlformats.org/drawingml/2006/main">
             <a:pPr algn="l">
+              <a:buNone/>
               <a:defRPr sz="1500" b="0">
                 <a:solidFill>
                   <a:srgbClr val="566975"/>
@@ -15726,6 +15826,7 @@
           <a:lstStyle xmlns:a="http://schemas.openxmlformats.org/drawingml/2006/main"/>
           <a:p xmlns:a="http://schemas.openxmlformats.org/drawingml/2006/main">
             <a:pPr algn="r">
+              <a:buNone/>
               <a:defRPr sz="1275" b="0">
                 <a:solidFill>
                   <a:srgbClr val="566975"/>
@@ -15751,14 +15852,14 @@
       </p:sp>
       <p:pic>
         <p:nvPicPr>
-          <p:cNvPr id="8" name=""/>
+          <p:cNvPr id="10" name=""/>
           <p:cNvPicPr>
             <a:picLocks xmlns:a="http://schemas.openxmlformats.org/drawingml/2006/main" noChangeAspect="1"/>
           </p:cNvPicPr>
           <p:nvPr/>
         </p:nvPicPr>
         <p:blipFill>
-          <a:blip xmlns:r="http://schemas.openxmlformats.org/officeDocument/2006/relationships" xmlns:a="http://schemas.openxmlformats.org/drawingml/2006/main" r:embed="Rc89e86ba9b1d4401"/>
+          <a:blip xmlns:r="http://schemas.openxmlformats.org/officeDocument/2006/relationships" xmlns:a="http://schemas.openxmlformats.org/drawingml/2006/main" r:embed="Rbd4e3dcbf3e1456d"/>
           <a:stretch xmlns:a="http://schemas.openxmlformats.org/drawingml/2006/main"/>
         </p:blipFill>
         <p:spPr>
@@ -15834,6 +15935,7 @@
           <a:lstStyle xmlns:a="http://schemas.openxmlformats.org/drawingml/2006/main"/>
           <a:p xmlns:a="http://schemas.openxmlformats.org/drawingml/2006/main">
             <a:pPr algn="l">
+              <a:buNone/>
               <a:defRPr sz="3300" b="1">
                 <a:solidFill>
                   <a:srgbClr val="19374D"/>
@@ -15891,6 +15993,7 @@
           <a:lstStyle xmlns:a="http://schemas.openxmlformats.org/drawingml/2006/main"/>
           <a:p xmlns:a="http://schemas.openxmlformats.org/drawingml/2006/main">
             <a:pPr algn="l">
+              <a:buNone/>
               <a:defRPr sz="1500" b="0">
                 <a:solidFill>
                   <a:srgbClr val="566975"/>
@@ -15948,6 +16051,7 @@
           <a:lstStyle xmlns:a="http://schemas.openxmlformats.org/drawingml/2006/main"/>
           <a:p xmlns:a="http://schemas.openxmlformats.org/drawingml/2006/main">
             <a:pPr algn="r">
+              <a:buNone/>
               <a:defRPr sz="1275" b="0">
                 <a:solidFill>
                   <a:srgbClr val="566975"/>
@@ -15973,7 +16077,7 @@
       </p:sp>
       <p:graphicFrame>
         <p:nvGraphicFramePr>
-          <p:cNvPr id="9" name=""/>
+          <p:cNvPr id="11" name=""/>
           <p:cNvGraphicFramePr/>
           <p:nvPr/>
         </p:nvGraphicFramePr>
@@ -16277,6 +16381,7 @@
           <a:lstStyle xmlns:a="http://schemas.openxmlformats.org/drawingml/2006/main"/>
           <a:p xmlns:a="http://schemas.openxmlformats.org/drawingml/2006/main">
             <a:pPr algn="l">
+              <a:buNone/>
               <a:defRPr sz="2025" b="0">
                 <a:solidFill>
                   <a:srgbClr val="253C4A"/>
@@ -16300,6 +16405,7 @@
           </a:p>
           <a:p xmlns:a="http://schemas.openxmlformats.org/drawingml/2006/main">
             <a:pPr algn="l">
+              <a:buNone/>
               <a:defRPr sz="2025" b="0">
                 <a:solidFill>
                   <a:srgbClr val="253C4A"/>
@@ -16386,6 +16492,7 @@
           <a:lstStyle xmlns:a="http://schemas.openxmlformats.org/drawingml/2006/main"/>
           <a:p xmlns:a="http://schemas.openxmlformats.org/drawingml/2006/main">
             <a:pPr algn="l">
+              <a:buNone/>
               <a:defRPr sz="3300" b="1">
                 <a:solidFill>
                   <a:srgbClr val="19374D"/>
@@ -16443,6 +16550,7 @@
           <a:lstStyle xmlns:a="http://schemas.openxmlformats.org/drawingml/2006/main"/>
           <a:p xmlns:a="http://schemas.openxmlformats.org/drawingml/2006/main">
             <a:pPr algn="l">
+              <a:buNone/>
               <a:defRPr sz="1500" b="0">
                 <a:solidFill>
                   <a:srgbClr val="566975"/>
@@ -16500,6 +16608,7 @@
           <a:lstStyle xmlns:a="http://schemas.openxmlformats.org/drawingml/2006/main"/>
           <a:p xmlns:a="http://schemas.openxmlformats.org/drawingml/2006/main">
             <a:pPr algn="r">
+              <a:buNone/>
               <a:defRPr sz="1275" b="0">
                 <a:solidFill>
                   <a:srgbClr val="566975"/>
@@ -16557,6 +16666,7 @@
           <a:lstStyle xmlns:a="http://schemas.openxmlformats.org/drawingml/2006/main"/>
           <a:p xmlns:a="http://schemas.openxmlformats.org/drawingml/2006/main">
             <a:pPr algn="l">
+              <a:buNone/>
               <a:defRPr sz="2625" b="1">
                 <a:solidFill>
                   <a:srgbClr val="008C83"/>
@@ -16614,6 +16724,7 @@
           <a:lstStyle xmlns:a="http://schemas.openxmlformats.org/drawingml/2006/main"/>
           <a:p xmlns:a="http://schemas.openxmlformats.org/drawingml/2006/main">
             <a:pPr algn="l">
+              <a:buNone/>
               <a:defRPr sz="2325" b="0">
                 <a:solidFill>
                   <a:srgbClr val="253C4A"/>
@@ -16637,6 +16748,7 @@
           </a:p>
           <a:p xmlns:a="http://schemas.openxmlformats.org/drawingml/2006/main">
             <a:pPr algn="l">
+              <a:buNone/>
               <a:defRPr sz="2325" b="0">
                 <a:solidFill>
                   <a:srgbClr val="253C4A"/>
@@ -16694,6 +16806,7 @@
           <a:lstStyle xmlns:a="http://schemas.openxmlformats.org/drawingml/2006/main"/>
           <a:p xmlns:a="http://schemas.openxmlformats.org/drawingml/2006/main">
             <a:pPr algn="l">
+              <a:buNone/>
               <a:defRPr sz="2325" b="0">
                 <a:solidFill>
                   <a:srgbClr val="253C4A"/>
@@ -16717,6 +16830,7 @@
           </a:p>
           <a:p xmlns:a="http://schemas.openxmlformats.org/drawingml/2006/main">
             <a:pPr algn="l">
+              <a:buNone/>
               <a:defRPr sz="2325" b="0">
                 <a:solidFill>
                   <a:srgbClr val="253C4A"/>
@@ -16774,6 +16888,7 @@
           <a:lstStyle xmlns:a="http://schemas.openxmlformats.org/drawingml/2006/main"/>
           <a:p xmlns:a="http://schemas.openxmlformats.org/drawingml/2006/main">
             <a:pPr algn="l">
+              <a:buNone/>
               <a:defRPr sz="1950" b="0">
                 <a:solidFill>
                   <a:srgbClr val="566975"/>
@@ -16860,6 +16975,7 @@
           <a:lstStyle xmlns:a="http://schemas.openxmlformats.org/drawingml/2006/main"/>
           <a:p xmlns:a="http://schemas.openxmlformats.org/drawingml/2006/main">
             <a:pPr algn="l">
+              <a:buNone/>
               <a:defRPr sz="3300" b="1">
                 <a:solidFill>
                   <a:srgbClr val="19374D"/>
@@ -16917,6 +17033,7 @@
           <a:lstStyle xmlns:a="http://schemas.openxmlformats.org/drawingml/2006/main"/>
           <a:p xmlns:a="http://schemas.openxmlformats.org/drawingml/2006/main">
             <a:pPr algn="l">
+              <a:buNone/>
               <a:defRPr sz="1500" b="0">
                 <a:solidFill>
                   <a:srgbClr val="566975"/>
@@ -16974,6 +17091,7 @@
           <a:lstStyle xmlns:a="http://schemas.openxmlformats.org/drawingml/2006/main"/>
           <a:p xmlns:a="http://schemas.openxmlformats.org/drawingml/2006/main">
             <a:pPr algn="r">
+              <a:buNone/>
               <a:defRPr sz="1275" b="0">
                 <a:solidFill>
                   <a:srgbClr val="566975"/>
@@ -16999,7 +17117,7 @@
       </p:sp>
       <p:graphicFrame>
         <p:nvGraphicFramePr>
-          <p:cNvPr id="8" name=""/>
+          <p:cNvPr id="10" name=""/>
           <p:cNvGraphicFramePr/>
           <p:nvPr/>
         </p:nvGraphicFramePr>
@@ -17453,6 +17571,7 @@
           <a:lstStyle xmlns:a="http://schemas.openxmlformats.org/drawingml/2006/main"/>
           <a:p xmlns:a="http://schemas.openxmlformats.org/drawingml/2006/main">
             <a:pPr algn="l">
+              <a:buNone/>
               <a:defRPr sz="3300" b="1">
                 <a:solidFill>
                   <a:srgbClr val="19374D"/>
@@ -17510,6 +17629,7 @@
           <a:lstStyle xmlns:a="http://schemas.openxmlformats.org/drawingml/2006/main"/>
           <a:p xmlns:a="http://schemas.openxmlformats.org/drawingml/2006/main">
             <a:pPr algn="l">
+              <a:buNone/>
               <a:defRPr sz="1500" b="0">
                 <a:solidFill>
                   <a:srgbClr val="566975"/>
@@ -17567,6 +17687,7 @@
           <a:lstStyle xmlns:a="http://schemas.openxmlformats.org/drawingml/2006/main"/>
           <a:p xmlns:a="http://schemas.openxmlformats.org/drawingml/2006/main">
             <a:pPr algn="r">
+              <a:buNone/>
               <a:defRPr sz="1275" b="0">
                 <a:solidFill>
                   <a:srgbClr val="566975"/>
@@ -17592,7 +17713,7 @@
       </p:sp>
       <p:graphicFrame>
         <p:nvGraphicFramePr>
-          <p:cNvPr id="9" name=""/>
+          <p:cNvPr id="11" name=""/>
           <p:cNvGraphicFramePr/>
           <p:nvPr/>
         </p:nvGraphicFramePr>
@@ -17882,6 +18003,7 @@
           <a:lstStyle xmlns:a="http://schemas.openxmlformats.org/drawingml/2006/main"/>
           <a:p xmlns:a="http://schemas.openxmlformats.org/drawingml/2006/main">
             <a:pPr algn="l">
+              <a:buNone/>
               <a:defRPr sz="2175" b="0">
                 <a:solidFill>
                   <a:srgbClr val="253C4A"/>
@@ -17905,6 +18027,7 @@
           </a:p>
           <a:p xmlns:a="http://schemas.openxmlformats.org/drawingml/2006/main">
             <a:pPr algn="l">
+              <a:buNone/>
               <a:defRPr sz="2175" b="0">
                 <a:solidFill>
                   <a:srgbClr val="253C4A"/>
@@ -17991,6 +18114,7 @@
           <a:lstStyle xmlns:a="http://schemas.openxmlformats.org/drawingml/2006/main"/>
           <a:p xmlns:a="http://schemas.openxmlformats.org/drawingml/2006/main">
             <a:pPr algn="l">
+              <a:buNone/>
               <a:defRPr sz="3300" b="1">
                 <a:solidFill>
                   <a:srgbClr val="19374D"/>
@@ -18048,6 +18172,7 @@
           <a:lstStyle xmlns:a="http://schemas.openxmlformats.org/drawingml/2006/main"/>
           <a:p xmlns:a="http://schemas.openxmlformats.org/drawingml/2006/main">
             <a:pPr algn="l">
+              <a:buNone/>
               <a:defRPr sz="1950" b="0">
                 <a:solidFill>
                   <a:srgbClr val="566975"/>
@@ -18105,6 +18230,7 @@
           <a:lstStyle xmlns:a="http://schemas.openxmlformats.org/drawingml/2006/main"/>
           <a:p xmlns:a="http://schemas.openxmlformats.org/drawingml/2006/main">
             <a:pPr algn="l">
+              <a:buNone/>
               <a:defRPr sz="1500" b="0">
                 <a:solidFill>
                   <a:srgbClr val="566975"/>
@@ -18162,6 +18288,7 @@
           <a:lstStyle xmlns:a="http://schemas.openxmlformats.org/drawingml/2006/main"/>
           <a:p xmlns:a="http://schemas.openxmlformats.org/drawingml/2006/main">
             <a:pPr algn="r">
+              <a:buNone/>
               <a:defRPr sz="1275" b="0">
                 <a:solidFill>
                   <a:srgbClr val="566975"/>
@@ -18187,7 +18314,7 @@
       </p:sp>
       <p:graphicFrame>
         <p:nvGraphicFramePr>
-          <p:cNvPr id="10" name=""/>
+          <p:cNvPr id="12" name=""/>
           <p:cNvGraphicFramePr/>
           <p:nvPr/>
         </p:nvGraphicFramePr>
@@ -18520,6 +18647,7 @@
           <a:lstStyle xmlns:a="http://schemas.openxmlformats.org/drawingml/2006/main"/>
           <a:p xmlns:a="http://schemas.openxmlformats.org/drawingml/2006/main">
             <a:pPr algn="l">
+              <a:buNone/>
               <a:defRPr sz="3300" b="1">
                 <a:solidFill>
                   <a:srgbClr val="19374D"/>
@@ -18577,6 +18705,7 @@
           <a:lstStyle xmlns:a="http://schemas.openxmlformats.org/drawingml/2006/main"/>
           <a:p xmlns:a="http://schemas.openxmlformats.org/drawingml/2006/main">
             <a:pPr algn="l">
+              <a:buNone/>
               <a:defRPr sz="1500" b="0">
                 <a:solidFill>
                   <a:srgbClr val="566975"/>
@@ -18634,6 +18763,7 @@
           <a:lstStyle xmlns:a="http://schemas.openxmlformats.org/drawingml/2006/main"/>
           <a:p xmlns:a="http://schemas.openxmlformats.org/drawingml/2006/main">
             <a:pPr algn="r">
+              <a:buNone/>
               <a:defRPr sz="1275" b="0">
                 <a:solidFill>
                   <a:srgbClr val="566975"/>
@@ -18659,7 +18789,7 @@
       </p:sp>
       <p:graphicFrame>
         <p:nvGraphicFramePr>
-          <p:cNvPr id="9" name=""/>
+          <p:cNvPr id="11" name=""/>
           <p:cNvGraphicFramePr/>
           <p:nvPr/>
         </p:nvGraphicFramePr>
@@ -19010,6 +19140,7 @@
           <a:lstStyle xmlns:a="http://schemas.openxmlformats.org/drawingml/2006/main"/>
           <a:p xmlns:a="http://schemas.openxmlformats.org/drawingml/2006/main">
             <a:pPr algn="l">
+              <a:buNone/>
               <a:defRPr sz="2175" b="0">
                 <a:solidFill>
                   <a:srgbClr val="253C4A"/>
@@ -19033,6 +19164,7 @@
           </a:p>
           <a:p xmlns:a="http://schemas.openxmlformats.org/drawingml/2006/main">
             <a:pPr algn="l">
+              <a:buNone/>
               <a:defRPr sz="2175" b="0">
                 <a:solidFill>
                   <a:srgbClr val="253C4A"/>
@@ -19119,6 +19251,7 @@
           <a:lstStyle xmlns:a="http://schemas.openxmlformats.org/drawingml/2006/main"/>
           <a:p xmlns:a="http://schemas.openxmlformats.org/drawingml/2006/main">
             <a:pPr algn="l">
+              <a:buNone/>
               <a:defRPr sz="3300" b="1">
                 <a:solidFill>
                   <a:srgbClr val="19374D"/>
@@ -19176,6 +19309,7 @@
           <a:lstStyle xmlns:a="http://schemas.openxmlformats.org/drawingml/2006/main"/>
           <a:p xmlns:a="http://schemas.openxmlformats.org/drawingml/2006/main">
             <a:pPr algn="l">
+              <a:buNone/>
               <a:defRPr sz="1500" b="0">
                 <a:solidFill>
                   <a:srgbClr val="566975"/>
@@ -19233,6 +19367,7 @@
           <a:lstStyle xmlns:a="http://schemas.openxmlformats.org/drawingml/2006/main"/>
           <a:p xmlns:a="http://schemas.openxmlformats.org/drawingml/2006/main">
             <a:pPr algn="r">
+              <a:buNone/>
               <a:defRPr sz="1275" b="0">
                 <a:solidFill>
                   <a:srgbClr val="566975"/>
@@ -19290,6 +19425,7 @@
           <a:lstStyle xmlns:a="http://schemas.openxmlformats.org/drawingml/2006/main"/>
           <a:p xmlns:a="http://schemas.openxmlformats.org/drawingml/2006/main">
             <a:pPr algn="l">
+              <a:buNone/>
               <a:defRPr sz="2550" b="1">
                 <a:solidFill>
                   <a:srgbClr val="008C83"/>
@@ -19315,7 +19451,7 @@
       </p:sp>
       <p:graphicFrame>
         <p:nvGraphicFramePr>
-          <p:cNvPr id="11" name=""/>
+          <p:cNvPr id="13" name=""/>
           <p:cNvGraphicFramePr/>
           <p:nvPr/>
         </p:nvGraphicFramePr>
@@ -19619,6 +19755,7 @@
           <a:lstStyle xmlns:a="http://schemas.openxmlformats.org/drawingml/2006/main"/>
           <a:p xmlns:a="http://schemas.openxmlformats.org/drawingml/2006/main">
             <a:pPr algn="l">
+              <a:buNone/>
               <a:defRPr sz="2175" b="0">
                 <a:solidFill>
                   <a:srgbClr val="253C4A"/>
@@ -19642,6 +19779,7 @@
           </a:p>
           <a:p xmlns:a="http://schemas.openxmlformats.org/drawingml/2006/main">
             <a:pPr algn="l">
+              <a:buNone/>
               <a:defRPr sz="2175" b="0">
                 <a:solidFill>
                   <a:srgbClr val="253C4A"/>
@@ -19670,6 +19808,7 @@
           </a:p>
           <a:p xmlns:a="http://schemas.openxmlformats.org/drawingml/2006/main">
             <a:pPr algn="l">
+              <a:buNone/>
               <a:defRPr sz="2175" b="0">
                 <a:solidFill>
                   <a:srgbClr val="253C4A"/>
@@ -19693,6 +19832,7 @@
           </a:p>
           <a:p xmlns:a="http://schemas.openxmlformats.org/drawingml/2006/main">
             <a:pPr algn="l">
+              <a:buNone/>
               <a:defRPr sz="2175" b="0">
                 <a:solidFill>
                   <a:srgbClr val="253C4A"/>
@@ -19779,6 +19919,7 @@
           <a:lstStyle xmlns:a="http://schemas.openxmlformats.org/drawingml/2006/main"/>
           <a:p xmlns:a="http://schemas.openxmlformats.org/drawingml/2006/main">
             <a:pPr algn="l">
+              <a:buNone/>
               <a:defRPr sz="3300" b="1">
                 <a:solidFill>
                   <a:srgbClr val="19374D"/>
@@ -19836,6 +19977,7 @@
           <a:lstStyle xmlns:a="http://schemas.openxmlformats.org/drawingml/2006/main"/>
           <a:p xmlns:a="http://schemas.openxmlformats.org/drawingml/2006/main">
             <a:pPr algn="l">
+              <a:buNone/>
               <a:defRPr sz="1950" b="0">
                 <a:solidFill>
                   <a:srgbClr val="566975"/>
@@ -19893,6 +20035,7 @@
           <a:lstStyle xmlns:a="http://schemas.openxmlformats.org/drawingml/2006/main"/>
           <a:p xmlns:a="http://schemas.openxmlformats.org/drawingml/2006/main">
             <a:pPr algn="r">
+              <a:buNone/>
               <a:defRPr sz="1275" b="0">
                 <a:solidFill>
                   <a:srgbClr val="566975"/>
@@ -19918,7 +20061,7 @@
       </p:sp>
       <p:graphicFrame>
         <p:nvGraphicFramePr>
-          <p:cNvPr id="9" name=""/>
+          <p:cNvPr id="11" name=""/>
           <p:cNvGraphicFramePr/>
           <p:nvPr/>
         </p:nvGraphicFramePr>
@@ -20269,6 +20412,7 @@
           <a:lstStyle xmlns:a="http://schemas.openxmlformats.org/drawingml/2006/main"/>
           <a:p xmlns:a="http://schemas.openxmlformats.org/drawingml/2006/main">
             <a:pPr algn="l">
+              <a:buNone/>
               <a:defRPr sz="2175" b="0">
                 <a:solidFill>
                   <a:srgbClr val="008C83"/>

</xml_diff>